<commit_message>
Add the demo video script, and correct the provenance-cell count
A 2:45 shot list with what to show, what to say, and the timing. Every
number it asks you to speak was checked against a live run first -- the
provenance-cell figure had drifted to 26,627 and is corrected in the
script, the deck, the README and the brief.

The script's own rule: never claim a number the screen is not showing at
that moment.

Co-Authored-By: Claude Opus 5 <noreply@anthropic.com>
</commit_message>
<xml_diff>
--- a/docs/deck/CALIPER_UniHack.pptx
+++ b/docs/deck/CALIPER_UniHack.pptx
@@ -4459,7 +4459,7 @@
                 </a:solidFill>
                 <a:latin typeface="Courier New"/>
               </a:rPr>
-              <a:t>26,492</a:t>
+              <a:t>26,627</a:t>
             </a:r>
           </a:p>
         </p:txBody>
@@ -6631,7 +6631,7 @@
                 </a:solidFill>
                 <a:latin typeface="Calibri"/>
               </a:rPr>
-              <a:t>26,492 cells, each traceable to the rule that made it and the characters behind it.</a:t>
+              <a:t>26,627 cells, each traceable to the rule that made it and the characters behind it.</a:t>
             </a:r>
           </a:p>
         </p:txBody>

</xml_diff>